<commit_message>
Agrega slide bonus track sobre finanzas inclusivas y fideicomiso de impacto (RADIM)
Co-Authored-By: Claude Opus 5.5 <noreply@anthropic.com>
Claude-Session: https://claude.ai/code/session_01LjZCUeZeukTqwmHG81QxgV
</commit_message>
<xml_diff>
--- a/presentaciones/crisis_fundar_radim.pptx
+++ b/presentaciones/crisis_fundar_radim.pptx
@@ -17,9 +17,10 @@
     <p:sldId id="265" r:id="rId11"/>
     <p:sldId id="266" r:id="rId12"/>
     <p:sldId id="267" r:id="rId13"/>
+    <p:sldId id="268" r:id="rId14"/>
   </p:sldIdLst>
   <p:notesMasterIdLst>
-    <p:notesMasterId r:id="rId14"/>
+    <p:notesMasterId r:id="rId15"/>
   </p:notesMasterIdLst>
   <p:sldSz cx="12192000" cy="6858000"/>
   <p:notesSz cx="6858000" cy="12192000"/>
@@ -118,12 +119,12 @@
   <p:extLst>
     <p:ext uri="{521415D9-36F7-43E2-AB2F-B90AF26B5E84}">
       <p14:sectionLst xmlns:p14="http://schemas.microsoft.com/office/powerpoint/2010/main">
-        <p14:section name="Portada" id="{2c9be519-763f-3407-44df-967b7a8663f6}">
+        <p14:section name="Portada" id="{bbb051e2-73fe-78dd-e9fd-ab820294ba14}">
           <p14:sldIdLst>
             <p14:sldId id="256"/>
           </p14:sldIdLst>
         </p14:section>
-        <p14:section name="Resumen" id="{b52a372f-a3fd-c045-01ea-6e594869cf57}">
+        <p14:section name="Resumen" id="{3642bdfc-66e7-547d-a179-8465caa74647}">
           <p14:sldIdLst>
             <p14:sldId id="257"/>
             <p14:sldId id="258"/>
@@ -131,7 +132,7 @@
             <p14:sldId id="260"/>
           </p14:sldIdLst>
         </p14:section>
-        <p14:section name="Cómo se armó" id="{cf96f5ce-217c-5e97-d29c-553e32879035}">
+        <p14:section name="Cómo se armó" id="{5744a0e5-b678-8a53-b08b-aade5419bd66}">
           <p14:sldIdLst>
             <p14:sldId id="261"/>
             <p14:sldId id="262"/>
@@ -139,11 +140,12 @@
             <p14:sldId id="264"/>
           </p14:sldIdLst>
         </p14:section>
-        <p14:section name="Qué hacer" id="{40cf627f-ea57-36d4-5e84-4748d8a4c4cc}">
+        <p14:section name="Qué hacer" id="{f9c50539-40d4-7574-a319-a85bf86f7cef}">
           <p14:sldIdLst>
             <p14:sldId id="265"/>
             <p14:sldId id="266"/>
             <p14:sldId id="267"/>
+            <p14:sldId id="268"/>
           </p14:sldIdLst>
         </p14:section>
       </p14:sectionLst>
@@ -4607,6 +4609,94 @@
 </p:notes>
 </file>
 
+<file path=ppt/notesSlides/notesSlide13.xml><?xml version="1.0" encoding="utf-8"?>
+<p:notes xmlns:a="http://schemas.openxmlformats.org/drawingml/2006/main" xmlns:r="http://schemas.openxmlformats.org/officeDocument/2006/relationships" xmlns:p="http://schemas.openxmlformats.org/presentationml/2006/main">
+  <p:cSld>
+    <p:spTree>
+      <p:nvGrpSpPr>
+        <p:cNvPr id="1" name=""/>
+        <p:cNvGrpSpPr/>
+        <p:nvPr/>
+      </p:nvGrpSpPr>
+      <p:grpSpPr>
+        <a:xfrm>
+          <a:off x="0" y="0"/>
+          <a:ext cx="0" cy="0"/>
+          <a:chOff x="0" y="0"/>
+          <a:chExt cx="0" cy="0"/>
+        </a:xfrm>
+      </p:grpSpPr>
+      <p:sp>
+        <p:nvSpPr>
+          <p:cNvPr id="2" name="Slide Image Placeholder 1"/>
+          <p:cNvSpPr>
+            <a:spLocks noGrp="1" noRot="1" noChangeAspect="1"/>
+          </p:cNvSpPr>
+          <p:nvPr>
+            <p:ph type="sldImg"/>
+          </p:nvPr>
+        </p:nvSpPr>
+        <p:spPr/>
+      </p:sp>
+      <p:sp>
+        <p:nvSpPr>
+          <p:cNvPr id="3" name="Notes Placeholder 2"/>
+          <p:cNvSpPr>
+            <a:spLocks noGrp="1"/>
+          </p:cNvSpPr>
+          <p:nvPr>
+            <p:ph type="body" idx="1"/>
+          </p:nvPr>
+        </p:nvSpPr>
+        <p:spPr/>
+        <p:txBody>
+          <a:bodyPr/>
+          <a:lstStyle/>
+          <a:p>
+            <a:r>
+              <a:rPr lang="en-US" dirty="0"/>
+              <a:t>Bonus track: cómo pensamos en Fundar las finanzas inclusivas. En el documento sobre barrios populares proponemos un fondo para canalizar inversión de impacto, combinando aportes con fondos de mercado. En esta etapa estamos armando un fideicomiso con inversores de impacto, como primer paso. Brecha de infraestructura: más de USD 27.000 millones (unos USD 2.250 millones por año durante 12 años). El FISU fue disuelto por el Decreto 312/2025.</a:t>
+            </a:r>
+            <a:endParaRPr lang="en-US" dirty="0"/>
+          </a:p>
+        </p:txBody>
+      </p:sp>
+      <p:sp>
+        <p:nvSpPr>
+          <p:cNvPr id="4" name="Slide Number Placeholder 3"/>
+          <p:cNvSpPr>
+            <a:spLocks noGrp="1"/>
+          </p:cNvSpPr>
+          <p:nvPr>
+            <p:ph type="sldNum" sz="quarter" idx="10"/>
+          </p:nvPr>
+        </p:nvSpPr>
+        <p:spPr/>
+        <p:txBody>
+          <a:bodyPr/>
+          <a:lstStyle/>
+          <a:p>
+            <a:fld id="{F7021451-1387-4CA6-816F-3879F97B5CBC}" type="slidenum">
+              <a:rPr lang="en-US"/>
+              <a:t>13</a:t>
+            </a:fld>
+            <a:endParaRPr lang="en-US"/>
+          </a:p>
+        </p:txBody>
+      </p:sp>
+    </p:spTree>
+    <p:extLst>
+      <p:ext uri="{BB962C8B-B14F-4D97-AF65-F5344CB8AC3E}">
+        <p14:creationId xmlns:p14="http://schemas.microsoft.com/office/powerpoint/2010/main" val="1024086991"/>
+      </p:ext>
+    </p:extLst>
+  </p:cSld>
+  <p:clrMapOvr>
+    <a:masterClrMapping/>
+  </p:clrMapOvr>
+</p:notes>
+</file>
+
 <file path=ppt/notesSlides/notesSlide2.xml><?xml version="1.0" encoding="utf-8"?>
 <p:notes xmlns:a="http://schemas.openxmlformats.org/drawingml/2006/main" xmlns:r="http://schemas.openxmlformats.org/officeDocument/2006/relationships" xmlns:p="http://schemas.openxmlformats.org/presentationml/2006/main">
   <p:cSld>
@@ -8441,6 +8531,901 @@
 </p:sld>
 </file>
 
+<file path=ppt/slides/slide13.xml><?xml version="1.0" encoding="utf-8"?>
+<p:sld xmlns:a="http://schemas.openxmlformats.org/drawingml/2006/main" xmlns:r="http://schemas.openxmlformats.org/officeDocument/2006/relationships" xmlns:p="http://schemas.openxmlformats.org/presentationml/2006/main">
+  <p:cSld name="Slide 13">
+    <p:spTree>
+      <p:nvGrpSpPr>
+        <p:cNvPr id="1" name=""/>
+        <p:cNvGrpSpPr/>
+        <p:nvPr/>
+      </p:nvGrpSpPr>
+      <p:grpSpPr>
+        <a:xfrm>
+          <a:off x="0" y="0"/>
+          <a:ext cx="0" cy="0"/>
+          <a:chOff x="0" y="0"/>
+          <a:chExt cx="0" cy="0"/>
+        </a:xfrm>
+      </p:grpSpPr>
+      <p:sp>
+        <p:nvSpPr>
+          <p:cNvPr id="2" name="Text 0"/>
+          <p:cNvSpPr txBox="1"/>
+          <p:nvPr/>
+        </p:nvSpPr>
+        <p:spPr>
+          <a:xfrm>
+            <a:off x="548640" y="502920"/>
+            <a:ext cx="8229600" cy="274320"/>
+          </a:xfrm>
+          <a:prstGeom prst="rect">
+            <a:avLst/>
+          </a:prstGeom>
+          <a:noFill/>
+          <a:ln/>
+        </p:spPr>
+        <p:txBody>
+          <a:bodyPr wrap="square" lIns="0" tIns="0" rIns="0" bIns="0" rtlCol="0" anchor="ctr"/>
+          <a:lstStyle/>
+          <a:p>
+            <a:pPr indent="0" marL="0">
+              <a:buNone/>
+            </a:pPr>
+            <a:r>
+              <a:rPr lang="en-US" sz="1300" b="1" spc="150" kern="0" dirty="0">
+                <a:solidFill>
+                  <a:srgbClr val="CDEFF2"/>
+                </a:solidFill>
+              </a:rPr>
+              <a:t>BONUS TRACK · FINANZAS INCLUSIVAS</a:t>
+            </a:r>
+            <a:endParaRPr lang="en-US" sz="1300" dirty="0"/>
+          </a:p>
+        </p:txBody>
+      </p:sp>
+      <p:sp>
+        <p:nvSpPr>
+          <p:cNvPr id="3" name="Text 1"/>
+          <p:cNvSpPr txBox="1"/>
+          <p:nvPr/>
+        </p:nvSpPr>
+        <p:spPr>
+          <a:xfrm>
+            <a:off x="548640" y="822960"/>
+            <a:ext cx="11094415" cy="640080"/>
+          </a:xfrm>
+          <a:prstGeom prst="rect">
+            <a:avLst/>
+          </a:prstGeom>
+          <a:noFill/>
+          <a:ln/>
+        </p:spPr>
+        <p:txBody>
+          <a:bodyPr wrap="square" lIns="0" tIns="0" rIns="0" bIns="0" rtlCol="0" anchor="ctr">
+            <a:normAutofit/>
+          </a:bodyPr>
+          <a:lstStyle/>
+          <a:p>
+            <a:pPr indent="0" marL="0">
+              <a:buNone/>
+            </a:pPr>
+            <a:r>
+              <a:rPr lang="en-US" sz="2800" b="1" dirty="0">
+                <a:solidFill>
+                  <a:schemeClr val="bg1"/>
+                </a:solidFill>
+              </a:rPr>
+              <a:t>De la propuesta a la inversión: un fideicomiso de impacto</a:t>
+            </a:r>
+            <a:endParaRPr lang="en-US" sz="2800" dirty="0"/>
+          </a:p>
+        </p:txBody>
+      </p:sp>
+      <p:sp>
+        <p:nvSpPr>
+          <p:cNvPr id="4" name="Bonus 1"/>
+          <p:cNvSpPr/>
+          <p:nvPr/>
+        </p:nvSpPr>
+        <p:spPr>
+          <a:xfrm>
+            <a:off x="548640" y="1874520"/>
+            <a:ext cx="3362858" cy="3886200"/>
+          </a:xfrm>
+          <a:prstGeom prst="roundRect">
+            <a:avLst>
+              <a:gd name="adj" fmla="val 4351"/>
+            </a:avLst>
+          </a:prstGeom>
+          <a:solidFill>
+            <a:schemeClr val="bg1"/>
+          </a:solidFill>
+          <a:ln/>
+        </p:spPr>
+      </p:sp>
+      <p:sp>
+        <p:nvSpPr>
+          <p:cNvPr id="5" name="Shape 3"/>
+          <p:cNvSpPr/>
+          <p:nvPr/>
+        </p:nvSpPr>
+        <p:spPr>
+          <a:xfrm>
+            <a:off x="822960" y="2148840"/>
+            <a:ext cx="502920" cy="502920"/>
+          </a:xfrm>
+          <a:prstGeom prst="ellipse">
+            <a:avLst/>
+          </a:prstGeom>
+          <a:solidFill>
+            <a:schemeClr val="accent1"/>
+          </a:solidFill>
+          <a:ln/>
+        </p:spPr>
+      </p:sp>
+      <p:sp>
+        <p:nvSpPr>
+          <p:cNvPr id="6" name="Shape 4"/>
+          <p:cNvSpPr/>
+          <p:nvPr/>
+        </p:nvSpPr>
+        <p:spPr>
+          <a:xfrm>
+            <a:off x="903427" y="2229307"/>
+            <a:ext cx="341986" cy="341986"/>
+          </a:xfrm>
+          <a:prstGeom prst="ellipse">
+            <a:avLst/>
+          </a:prstGeom>
+          <a:ln w="20955">
+            <a:solidFill>
+              <a:srgbClr val="B8432F"/>
+            </a:solidFill>
+            <a:prstDash val="solid"/>
+          </a:ln>
+        </p:spPr>
+      </p:sp>
+      <p:sp>
+        <p:nvSpPr>
+          <p:cNvPr id="7" name="Text 5"/>
+          <p:cNvSpPr txBox="1"/>
+          <p:nvPr/>
+        </p:nvSpPr>
+        <p:spPr>
+          <a:xfrm>
+            <a:off x="1463040" y="2194560"/>
+            <a:ext cx="2265578" cy="411480"/>
+          </a:xfrm>
+          <a:prstGeom prst="rect">
+            <a:avLst/>
+          </a:prstGeom>
+          <a:noFill/>
+          <a:ln/>
+        </p:spPr>
+        <p:txBody>
+          <a:bodyPr wrap="square" lIns="0" tIns="0" rIns="0" bIns="0" rtlCol="0" anchor="ctr"/>
+          <a:lstStyle/>
+          <a:p>
+            <a:pPr indent="0" marL="0">
+              <a:buNone/>
+            </a:pPr>
+            <a:r>
+              <a:rPr lang="en-US" sz="1100" b="1" spc="150" kern="0" dirty="0">
+                <a:solidFill>
+                  <a:schemeClr val="tx2"/>
+                </a:solidFill>
+              </a:rPr>
+              <a:t>EL PROBLEMA</a:t>
+            </a:r>
+            <a:endParaRPr lang="en-US" sz="1100" dirty="0"/>
+          </a:p>
+        </p:txBody>
+      </p:sp>
+      <p:sp>
+        <p:nvSpPr>
+          <p:cNvPr id="8" name="Text 6"/>
+          <p:cNvSpPr txBox="1"/>
+          <p:nvPr/>
+        </p:nvSpPr>
+        <p:spPr>
+          <a:xfrm>
+            <a:off x="822960" y="2834640"/>
+            <a:ext cx="2814218" cy="548640"/>
+          </a:xfrm>
+          <a:prstGeom prst="rect">
+            <a:avLst/>
+          </a:prstGeom>
+          <a:noFill/>
+          <a:ln/>
+        </p:spPr>
+        <p:txBody>
+          <a:bodyPr wrap="square" lIns="0" tIns="0" rIns="0" bIns="0" rtlCol="0" anchor="ctr">
+            <a:normAutofit/>
+          </a:bodyPr>
+          <a:lstStyle/>
+          <a:p>
+            <a:pPr indent="0" marL="0">
+              <a:buNone/>
+            </a:pPr>
+            <a:r>
+              <a:rPr lang="en-US" sz="2600" b="1" dirty="0">
+                <a:solidFill>
+                  <a:schemeClr val="tx1"/>
+                </a:solidFill>
+              </a:rPr>
+              <a:t>USD 27.000 M</a:t>
+            </a:r>
+            <a:endParaRPr lang="en-US" sz="2600" dirty="0"/>
+          </a:p>
+        </p:txBody>
+      </p:sp>
+      <p:sp>
+        <p:nvSpPr>
+          <p:cNvPr id="9" name="Text 7"/>
+          <p:cNvSpPr txBox="1"/>
+          <p:nvPr/>
+        </p:nvSpPr>
+        <p:spPr>
+          <a:xfrm>
+            <a:off x="822960" y="3429000"/>
+            <a:ext cx="2814218" cy="731520"/>
+          </a:xfrm>
+          <a:prstGeom prst="rect">
+            <a:avLst/>
+          </a:prstGeom>
+          <a:noFill/>
+          <a:ln/>
+        </p:spPr>
+        <p:txBody>
+          <a:bodyPr wrap="square" lIns="0" tIns="0" rIns="0" bIns="0" rtlCol="0" anchor="t"/>
+          <a:lstStyle/>
+          <a:p>
+            <a:pPr indent="0" marL="0">
+              <a:buNone/>
+            </a:pPr>
+            <a:r>
+              <a:rPr lang="en-US" sz="1500" b="1" dirty="0">
+                <a:solidFill>
+                  <a:schemeClr val="accent3"/>
+                </a:solidFill>
+              </a:rPr>
+              <a:t>de brecha de infraestructura en los barrios populares</a:t>
+            </a:r>
+            <a:endParaRPr lang="en-US" sz="1500" dirty="0"/>
+          </a:p>
+        </p:txBody>
+      </p:sp>
+      <p:sp>
+        <p:nvSpPr>
+          <p:cNvPr id="10" name="Text 8"/>
+          <p:cNvSpPr txBox="1"/>
+          <p:nvPr/>
+        </p:nvSpPr>
+        <p:spPr>
+          <a:xfrm>
+            <a:off x="822960" y="4251960"/>
+            <a:ext cx="2814218" cy="1005840"/>
+          </a:xfrm>
+          <a:prstGeom prst="rect">
+            <a:avLst/>
+          </a:prstGeom>
+          <a:noFill/>
+          <a:ln/>
+        </p:spPr>
+        <p:txBody>
+          <a:bodyPr wrap="square" lIns="0" tIns="0" rIns="0" bIns="0" rtlCol="0" anchor="t"/>
+          <a:lstStyle/>
+          <a:p>
+            <a:pPr indent="0" marL="0">
+              <a:buNone/>
+            </a:pPr>
+            <a:r>
+              <a:rPr lang="en-US" sz="1400" dirty="0">
+                <a:solidFill>
+                  <a:schemeClr val="tx2"/>
+                </a:solidFill>
+              </a:rPr>
+              <a:t>Unos USD 2.250 M por año durante 12 años. El FISU, que financiaba la integración sociourbana, fue disuelto en 2025.</a:t>
+            </a:r>
+            <a:endParaRPr lang="en-US" sz="1400" dirty="0"/>
+          </a:p>
+        </p:txBody>
+      </p:sp>
+      <p:sp>
+        <p:nvSpPr>
+          <p:cNvPr id="11" name="Text 9"/>
+          <p:cNvSpPr txBox="1"/>
+          <p:nvPr/>
+        </p:nvSpPr>
+        <p:spPr>
+          <a:xfrm>
+            <a:off x="3957218" y="3337560"/>
+            <a:ext cx="411480" cy="548640"/>
+          </a:xfrm>
+          <a:prstGeom prst="rect">
+            <a:avLst/>
+          </a:prstGeom>
+          <a:noFill/>
+          <a:ln/>
+        </p:spPr>
+        <p:txBody>
+          <a:bodyPr wrap="square" lIns="0" tIns="0" rIns="0" bIns="0" rtlCol="0" anchor="ctr"/>
+          <a:lstStyle/>
+          <a:p>
+            <a:pPr algn="ctr" indent="0" marL="0">
+              <a:buNone/>
+            </a:pPr>
+            <a:r>
+              <a:rPr lang="en-US" sz="3000" b="1" dirty="0">
+                <a:solidFill>
+                  <a:schemeClr val="accent2"/>
+                </a:solidFill>
+              </a:rPr>
+              <a:t>→</a:t>
+            </a:r>
+            <a:endParaRPr lang="en-US" sz="3000" dirty="0"/>
+          </a:p>
+        </p:txBody>
+      </p:sp>
+      <p:sp>
+        <p:nvSpPr>
+          <p:cNvPr id="12" name="Bonus 2"/>
+          <p:cNvSpPr/>
+          <p:nvPr/>
+        </p:nvSpPr>
+        <p:spPr>
+          <a:xfrm>
+            <a:off x="4414418" y="1874520"/>
+            <a:ext cx="3362858" cy="3886200"/>
+          </a:xfrm>
+          <a:prstGeom prst="roundRect">
+            <a:avLst>
+              <a:gd name="adj" fmla="val 4351"/>
+            </a:avLst>
+          </a:prstGeom>
+          <a:solidFill>
+            <a:schemeClr val="bg1"/>
+          </a:solidFill>
+          <a:ln/>
+        </p:spPr>
+      </p:sp>
+      <p:sp>
+        <p:nvSpPr>
+          <p:cNvPr id="13" name="Shape 11"/>
+          <p:cNvSpPr/>
+          <p:nvPr/>
+        </p:nvSpPr>
+        <p:spPr>
+          <a:xfrm>
+            <a:off x="4688738" y="2148840"/>
+            <a:ext cx="502920" cy="502920"/>
+          </a:xfrm>
+          <a:prstGeom prst="ellipse">
+            <a:avLst/>
+          </a:prstGeom>
+          <a:solidFill>
+            <a:schemeClr val="accent2"/>
+          </a:solidFill>
+          <a:ln/>
+        </p:spPr>
+      </p:sp>
+      <p:sp>
+        <p:nvSpPr>
+          <p:cNvPr id="14" name="Shape 12"/>
+          <p:cNvSpPr/>
+          <p:nvPr/>
+        </p:nvSpPr>
+        <p:spPr>
+          <a:xfrm>
+            <a:off x="4769206" y="2229307"/>
+            <a:ext cx="341986" cy="341986"/>
+          </a:xfrm>
+          <a:prstGeom prst="ellipse">
+            <a:avLst/>
+          </a:prstGeom>
+          <a:ln w="20955">
+            <a:solidFill>
+              <a:srgbClr val="C98A12"/>
+            </a:solidFill>
+            <a:prstDash val="solid"/>
+          </a:ln>
+        </p:spPr>
+      </p:sp>
+      <p:sp>
+        <p:nvSpPr>
+          <p:cNvPr id="15" name="Text 13"/>
+          <p:cNvSpPr txBox="1"/>
+          <p:nvPr/>
+        </p:nvSpPr>
+        <p:spPr>
+          <a:xfrm>
+            <a:off x="5328818" y="2194560"/>
+            <a:ext cx="2265578" cy="411480"/>
+          </a:xfrm>
+          <a:prstGeom prst="rect">
+            <a:avLst/>
+          </a:prstGeom>
+          <a:noFill/>
+          <a:ln/>
+        </p:spPr>
+        <p:txBody>
+          <a:bodyPr wrap="square" lIns="0" tIns="0" rIns="0" bIns="0" rtlCol="0" anchor="ctr"/>
+          <a:lstStyle/>
+          <a:p>
+            <a:pPr indent="0" marL="0">
+              <a:buNone/>
+            </a:pPr>
+            <a:r>
+              <a:rPr lang="en-US" sz="1100" b="1" spc="150" kern="0" dirty="0">
+                <a:solidFill>
+                  <a:schemeClr val="tx2"/>
+                </a:solidFill>
+              </a:rPr>
+              <a:t>LA PROPUESTA DE FUNDAR</a:t>
+            </a:r>
+            <a:endParaRPr lang="en-US" sz="1100" dirty="0"/>
+          </a:p>
+        </p:txBody>
+      </p:sp>
+      <p:sp>
+        <p:nvSpPr>
+          <p:cNvPr id="16" name="Text 14"/>
+          <p:cNvSpPr txBox="1"/>
+          <p:nvPr/>
+        </p:nvSpPr>
+        <p:spPr>
+          <a:xfrm>
+            <a:off x="4688738" y="2834640"/>
+            <a:ext cx="2814218" cy="548640"/>
+          </a:xfrm>
+          <a:prstGeom prst="rect">
+            <a:avLst/>
+          </a:prstGeom>
+          <a:noFill/>
+          <a:ln/>
+        </p:spPr>
+        <p:txBody>
+          <a:bodyPr wrap="square" lIns="0" tIns="0" rIns="0" bIns="0" rtlCol="0" anchor="ctr">
+            <a:normAutofit/>
+          </a:bodyPr>
+          <a:lstStyle/>
+          <a:p>
+            <a:pPr indent="0" marL="0">
+              <a:buNone/>
+            </a:pPr>
+            <a:r>
+              <a:rPr lang="en-US" sz="2600" b="1" dirty="0">
+                <a:solidFill>
+                  <a:schemeClr val="tx1"/>
+                </a:solidFill>
+              </a:rPr>
+              <a:t>Fondo de impacto</a:t>
+            </a:r>
+            <a:endParaRPr lang="en-US" sz="2600" dirty="0"/>
+          </a:p>
+        </p:txBody>
+      </p:sp>
+      <p:sp>
+        <p:nvSpPr>
+          <p:cNvPr id="17" name="Text 15"/>
+          <p:cNvSpPr txBox="1"/>
+          <p:nvPr/>
+        </p:nvSpPr>
+        <p:spPr>
+          <a:xfrm>
+            <a:off x="4688738" y="3429000"/>
+            <a:ext cx="2814218" cy="731520"/>
+          </a:xfrm>
+          <a:prstGeom prst="rect">
+            <a:avLst/>
+          </a:prstGeom>
+          <a:noFill/>
+          <a:ln/>
+        </p:spPr>
+        <p:txBody>
+          <a:bodyPr wrap="square" lIns="0" tIns="0" rIns="0" bIns="0" rtlCol="0" anchor="t"/>
+          <a:lstStyle/>
+          <a:p>
+            <a:pPr indent="0" marL="0">
+              <a:buNone/>
+            </a:pPr>
+            <a:r>
+              <a:rPr lang="en-US" sz="1500" b="1" dirty="0">
+                <a:solidFill>
+                  <a:schemeClr val="accent3"/>
+                </a:solidFill>
+              </a:rPr>
+              <a:t>para canalizar inversión de impacto</a:t>
+            </a:r>
+            <a:endParaRPr lang="en-US" sz="1500" dirty="0"/>
+          </a:p>
+        </p:txBody>
+      </p:sp>
+      <p:sp>
+        <p:nvSpPr>
+          <p:cNvPr id="18" name="Text 16"/>
+          <p:cNvSpPr txBox="1"/>
+          <p:nvPr/>
+        </p:nvSpPr>
+        <p:spPr>
+          <a:xfrm>
+            <a:off x="4688738" y="4251960"/>
+            <a:ext cx="2814218" cy="1005840"/>
+          </a:xfrm>
+          <a:prstGeom prst="rect">
+            <a:avLst/>
+          </a:prstGeom>
+          <a:noFill/>
+          <a:ln/>
+        </p:spPr>
+        <p:txBody>
+          <a:bodyPr wrap="square" lIns="0" tIns="0" rIns="0" bIns="0" rtlCol="0" anchor="t"/>
+          <a:lstStyle/>
+          <a:p>
+            <a:pPr indent="0" marL="0">
+              <a:buNone/>
+            </a:pPr>
+            <a:r>
+              <a:rPr lang="en-US" sz="1400" dirty="0">
+                <a:solidFill>
+                  <a:schemeClr val="tx2"/>
+                </a:solidFill>
+              </a:rPr>
+              <a:t>Combinar aportes con fondos de mercado para ganar escala y velocidad en las intervenciones.</a:t>
+            </a:r>
+            <a:endParaRPr lang="en-US" sz="1400" dirty="0"/>
+          </a:p>
+        </p:txBody>
+      </p:sp>
+      <p:sp>
+        <p:nvSpPr>
+          <p:cNvPr id="19" name="Text 17"/>
+          <p:cNvSpPr txBox="1"/>
+          <p:nvPr/>
+        </p:nvSpPr>
+        <p:spPr>
+          <a:xfrm>
+            <a:off x="7822997" y="3337560"/>
+            <a:ext cx="411480" cy="548640"/>
+          </a:xfrm>
+          <a:prstGeom prst="rect">
+            <a:avLst/>
+          </a:prstGeom>
+          <a:noFill/>
+          <a:ln/>
+        </p:spPr>
+        <p:txBody>
+          <a:bodyPr wrap="square" lIns="0" tIns="0" rIns="0" bIns="0" rtlCol="0" anchor="ctr"/>
+          <a:lstStyle/>
+          <a:p>
+            <a:pPr algn="ctr" indent="0" marL="0">
+              <a:buNone/>
+            </a:pPr>
+            <a:r>
+              <a:rPr lang="en-US" sz="3000" b="1" dirty="0">
+                <a:solidFill>
+                  <a:schemeClr val="accent2"/>
+                </a:solidFill>
+              </a:rPr>
+              <a:t>→</a:t>
+            </a:r>
+            <a:endParaRPr lang="en-US" sz="3000" dirty="0"/>
+          </a:p>
+        </p:txBody>
+      </p:sp>
+      <p:sp>
+        <p:nvSpPr>
+          <p:cNvPr id="20" name="Bonus 3"/>
+          <p:cNvSpPr/>
+          <p:nvPr/>
+        </p:nvSpPr>
+        <p:spPr>
+          <a:xfrm>
+            <a:off x="8280197" y="1874520"/>
+            <a:ext cx="3362858" cy="3886200"/>
+          </a:xfrm>
+          <a:prstGeom prst="roundRect">
+            <a:avLst>
+              <a:gd name="adj" fmla="val 4351"/>
+            </a:avLst>
+          </a:prstGeom>
+          <a:solidFill>
+            <a:schemeClr val="bg1"/>
+          </a:solidFill>
+          <a:ln/>
+        </p:spPr>
+      </p:sp>
+      <p:sp>
+        <p:nvSpPr>
+          <p:cNvPr id="21" name="Shape 19"/>
+          <p:cNvSpPr/>
+          <p:nvPr/>
+        </p:nvSpPr>
+        <p:spPr>
+          <a:xfrm>
+            <a:off x="8554517" y="2148840"/>
+            <a:ext cx="502920" cy="502920"/>
+          </a:xfrm>
+          <a:prstGeom prst="ellipse">
+            <a:avLst/>
+          </a:prstGeom>
+          <a:solidFill>
+            <a:schemeClr val="accent3"/>
+          </a:solidFill>
+          <a:ln/>
+        </p:spPr>
+      </p:sp>
+      <p:sp>
+        <p:nvSpPr>
+          <p:cNvPr id="22" name="Shape 20"/>
+          <p:cNvSpPr/>
+          <p:nvPr/>
+        </p:nvSpPr>
+        <p:spPr>
+          <a:xfrm>
+            <a:off x="8634984" y="2229307"/>
+            <a:ext cx="341986" cy="341986"/>
+          </a:xfrm>
+          <a:prstGeom prst="ellipse">
+            <a:avLst/>
+          </a:prstGeom>
+          <a:ln w="20955">
+            <a:solidFill>
+              <a:srgbClr val="006E7A"/>
+            </a:solidFill>
+            <a:prstDash val="solid"/>
+          </a:ln>
+        </p:spPr>
+      </p:sp>
+      <p:sp>
+        <p:nvSpPr>
+          <p:cNvPr id="23" name="Text 21"/>
+          <p:cNvSpPr txBox="1"/>
+          <p:nvPr/>
+        </p:nvSpPr>
+        <p:spPr>
+          <a:xfrm>
+            <a:off x="9194597" y="2194560"/>
+            <a:ext cx="2265578" cy="411480"/>
+          </a:xfrm>
+          <a:prstGeom prst="rect">
+            <a:avLst/>
+          </a:prstGeom>
+          <a:noFill/>
+          <a:ln/>
+        </p:spPr>
+        <p:txBody>
+          <a:bodyPr wrap="square" lIns="0" tIns="0" rIns="0" bIns="0" rtlCol="0" anchor="ctr"/>
+          <a:lstStyle/>
+          <a:p>
+            <a:pPr indent="0" marL="0">
+              <a:buNone/>
+            </a:pPr>
+            <a:r>
+              <a:rPr lang="en-US" sz="1100" b="1" spc="150" kern="0" dirty="0">
+                <a:solidFill>
+                  <a:schemeClr val="tx2"/>
+                </a:solidFill>
+              </a:rPr>
+              <a:t>EN QUÉ ESTAMOS</a:t>
+            </a:r>
+            <a:endParaRPr lang="en-US" sz="1100" dirty="0"/>
+          </a:p>
+        </p:txBody>
+      </p:sp>
+      <p:sp>
+        <p:nvSpPr>
+          <p:cNvPr id="24" name="Text 22"/>
+          <p:cNvSpPr txBox="1"/>
+          <p:nvPr/>
+        </p:nvSpPr>
+        <p:spPr>
+          <a:xfrm>
+            <a:off x="8554517" y="2834640"/>
+            <a:ext cx="2814218" cy="548640"/>
+          </a:xfrm>
+          <a:prstGeom prst="rect">
+            <a:avLst/>
+          </a:prstGeom>
+          <a:noFill/>
+          <a:ln/>
+        </p:spPr>
+        <p:txBody>
+          <a:bodyPr wrap="square" lIns="0" tIns="0" rIns="0" bIns="0" rtlCol="0" anchor="ctr">
+            <a:normAutofit/>
+          </a:bodyPr>
+          <a:lstStyle/>
+          <a:p>
+            <a:pPr indent="0" marL="0">
+              <a:buNone/>
+            </a:pPr>
+            <a:r>
+              <a:rPr lang="en-US" sz="2600" b="1" dirty="0">
+                <a:solidFill>
+                  <a:schemeClr val="tx1"/>
+                </a:solidFill>
+              </a:rPr>
+              <a:t>Un fideicomiso</a:t>
+            </a:r>
+            <a:endParaRPr lang="en-US" sz="2600" dirty="0"/>
+          </a:p>
+        </p:txBody>
+      </p:sp>
+      <p:sp>
+        <p:nvSpPr>
+          <p:cNvPr id="25" name="Text 23"/>
+          <p:cNvSpPr txBox="1"/>
+          <p:nvPr/>
+        </p:nvSpPr>
+        <p:spPr>
+          <a:xfrm>
+            <a:off x="8554517" y="3429000"/>
+            <a:ext cx="2814218" cy="731520"/>
+          </a:xfrm>
+          <a:prstGeom prst="rect">
+            <a:avLst/>
+          </a:prstGeom>
+          <a:noFill/>
+          <a:ln/>
+        </p:spPr>
+        <p:txBody>
+          <a:bodyPr wrap="square" lIns="0" tIns="0" rIns="0" bIns="0" rtlCol="0" anchor="t"/>
+          <a:lstStyle/>
+          <a:p>
+            <a:pPr indent="0" marL="0">
+              <a:buNone/>
+            </a:pPr>
+            <a:r>
+              <a:rPr lang="en-US" sz="1500" b="1" dirty="0">
+                <a:solidFill>
+                  <a:schemeClr val="accent3"/>
+                </a:solidFill>
+              </a:rPr>
+              <a:t>con inversores de impacto, como primer paso</a:t>
+            </a:r>
+            <a:endParaRPr lang="en-US" sz="1500" dirty="0"/>
+          </a:p>
+        </p:txBody>
+      </p:sp>
+      <p:sp>
+        <p:nvSpPr>
+          <p:cNvPr id="26" name="Text 24"/>
+          <p:cNvSpPr txBox="1"/>
+          <p:nvPr/>
+        </p:nvSpPr>
+        <p:spPr>
+          <a:xfrm>
+            <a:off x="8554517" y="4251960"/>
+            <a:ext cx="2814218" cy="1005840"/>
+          </a:xfrm>
+          <a:prstGeom prst="rect">
+            <a:avLst/>
+          </a:prstGeom>
+          <a:noFill/>
+          <a:ln/>
+        </p:spPr>
+        <p:txBody>
+          <a:bodyPr wrap="square" lIns="0" tIns="0" rIns="0" bIns="0" rtlCol="0" anchor="t"/>
+          <a:lstStyle/>
+          <a:p>
+            <a:pPr indent="0" marL="0">
+              <a:buNone/>
+            </a:pPr>
+            <a:r>
+              <a:rPr lang="en-US" sz="1400" dirty="0">
+                <a:solidFill>
+                  <a:schemeClr val="tx2"/>
+                </a:solidFill>
+              </a:rPr>
+              <a:t>Lo estamos armando: es el primer paso para probar el esquema antes de sumar fondos de mercado.</a:t>
+            </a:r>
+            <a:endParaRPr lang="en-US" sz="1400" dirty="0"/>
+          </a:p>
+        </p:txBody>
+      </p:sp>
+      <p:sp>
+        <p:nvSpPr>
+          <p:cNvPr id="27" name="Shape 25"/>
+          <p:cNvSpPr/>
+          <p:nvPr/>
+        </p:nvSpPr>
+        <p:spPr>
+          <a:xfrm>
+            <a:off x="8554517" y="5303520"/>
+            <a:ext cx="1600200" cy="329184"/>
+          </a:xfrm>
+          <a:prstGeom prst="roundRect">
+            <a:avLst>
+              <a:gd name="adj" fmla="val 50000"/>
+            </a:avLst>
+          </a:prstGeom>
+          <a:solidFill>
+            <a:schemeClr val="accent2"/>
+          </a:solidFill>
+          <a:ln/>
+        </p:spPr>
+      </p:sp>
+      <p:sp>
+        <p:nvSpPr>
+          <p:cNvPr id="28" name="Text 26"/>
+          <p:cNvSpPr txBox="1"/>
+          <p:nvPr/>
+        </p:nvSpPr>
+        <p:spPr>
+          <a:xfrm>
+            <a:off x="8554517" y="5303520"/>
+            <a:ext cx="1600200" cy="329184"/>
+          </a:xfrm>
+          <a:prstGeom prst="rect">
+            <a:avLst/>
+          </a:prstGeom>
+          <a:noFill/>
+          <a:ln/>
+        </p:spPr>
+        <p:txBody>
+          <a:bodyPr wrap="square" lIns="0" tIns="0" rIns="0" bIns="0" rtlCol="0" anchor="ctr"/>
+          <a:lstStyle/>
+          <a:p>
+            <a:pPr algn="ctr" indent="0" marL="0">
+              <a:buNone/>
+            </a:pPr>
+            <a:r>
+              <a:rPr lang="en-US" sz="1100" b="1" spc="150" kern="0" dirty="0">
+                <a:solidFill>
+                  <a:schemeClr val="tx1"/>
+                </a:solidFill>
+              </a:rPr>
+              <a:t>EN ARMADO</a:t>
+            </a:r>
+            <a:endParaRPr lang="en-US" sz="1100" dirty="0"/>
+          </a:p>
+        </p:txBody>
+      </p:sp>
+      <p:sp>
+        <p:nvSpPr>
+          <p:cNvPr id="29" name="Text 27"/>
+          <p:cNvSpPr txBox="1"/>
+          <p:nvPr/>
+        </p:nvSpPr>
+        <p:spPr>
+          <a:xfrm>
+            <a:off x="1554480" y="6053328"/>
+            <a:ext cx="7315200" cy="256032"/>
+          </a:xfrm>
+          <a:prstGeom prst="rect">
+            <a:avLst/>
+          </a:prstGeom>
+          <a:noFill/>
+          <a:ln/>
+        </p:spPr>
+        <p:txBody>
+          <a:bodyPr wrap="square" lIns="0" tIns="0" rIns="0" bIns="0" rtlCol="0" anchor="ctr"/>
+          <a:lstStyle/>
+          <a:p>
+            <a:pPr indent="0" marL="0">
+              <a:buNone/>
+            </a:pPr>
+            <a:r>
+              <a:rPr lang="en-US" sz="1000" dirty="0">
+                <a:solidFill>
+                  <a:srgbClr val="E6F6F7"/>
+                </a:solidFill>
+              </a:rPr>
+              <a:t>Fuente: Fundar, De los barrios populares a la ciudad formal. Aportes para un plan (2025).</a:t>
+            </a:r>
+            <a:endParaRPr lang="en-US" sz="1000" dirty="0"/>
+          </a:p>
+        </p:txBody>
+      </p:sp>
+    </p:spTree>
+  </p:cSld>
+  <p:clrMapOvr>
+    <a:masterClrMapping/>
+  </p:clrMapOvr>
+</p:sld>
+</file>
+
 <file path=ppt/slides/slide2.xml><?xml version="1.0" encoding="utf-8"?>
 <p:sld xmlns:a="http://schemas.openxmlformats.org/drawingml/2006/main" xmlns:r="http://schemas.openxmlformats.org/officeDocument/2006/relationships" xmlns:p="http://schemas.openxmlformats.org/presentationml/2006/main">
   <p:cSld name="Slide 2">
@@ -14320,14 +15305,14 @@
               <a:buNone/>
             </a:pPr>
             <a:r>
-              <a:rPr lang="en-US" sz="2600" b="1" dirty="0">
+              <a:rPr lang="en-US" sz="2400" b="1" dirty="0">
                 <a:solidFill>
                   <a:schemeClr val="tx1"/>
                 </a:solidFill>
               </a:rPr>
               <a:t>1 de cada 8</a:t>
             </a:r>
-            <a:endParaRPr lang="en-US" sz="2600" dirty="0"/>
+            <a:endParaRPr lang="en-US" sz="2400" dirty="0"/>
           </a:p>
         </p:txBody>
       </p:sp>
@@ -14457,14 +15442,14 @@
               <a:buNone/>
             </a:pPr>
             <a:r>
-              <a:rPr lang="en-US" sz="2600" b="1" dirty="0">
+              <a:rPr lang="en-US" sz="2400" b="1" dirty="0">
                 <a:solidFill>
                   <a:schemeClr val="tx1"/>
                 </a:solidFill>
               </a:rPr>
               <a:t>$17,8</a:t>
             </a:r>
-            <a:endParaRPr lang="en-US" sz="2600" dirty="0"/>
+            <a:endParaRPr lang="en-US" sz="2400" dirty="0"/>
           </a:p>
         </p:txBody>
       </p:sp>
@@ -14594,14 +15579,14 @@
               <a:buNone/>
             </a:pPr>
             <a:r>
-              <a:rPr lang="en-US" sz="2600" b="1" dirty="0">
+              <a:rPr lang="en-US" sz="2400" b="1" dirty="0">
                 <a:solidFill>
                   <a:schemeClr val="tx1"/>
                 </a:solidFill>
               </a:rPr>
               <a:t>6 de cada 10</a:t>
             </a:r>
-            <a:endParaRPr lang="en-US" sz="2600" dirty="0"/>
+            <a:endParaRPr lang="en-US" sz="2400" dirty="0"/>
           </a:p>
         </p:txBody>
       </p:sp>

</xml_diff>

<commit_message>
Rediseña la slide de microfinanzas como dilemas con balanza (RADIM)
Co-Authored-By: Claude Opus 5.5 <noreply@anthropic.com>
Claude-Session: https://claude.ai/code/session_01LjZCUeZeukTqwmHG81QxgV
</commit_message>
<xml_diff>
--- a/presentaciones/crisis_fundar_radim.pptx
+++ b/presentaciones/crisis_fundar_radim.pptx
@@ -119,12 +119,12 @@
   <p:extLst>
     <p:ext uri="{521415D9-36F7-43E2-AB2F-B90AF26B5E84}">
       <p14:sectionLst xmlns:p14="http://schemas.microsoft.com/office/powerpoint/2010/main">
-        <p14:section name="Portada" id="{bbb051e2-73fe-78dd-e9fd-ab820294ba14}">
+        <p14:section name="Portada" id="{9c4f3877-3a6f-b0a2-54d3-b59271752e04}">
           <p14:sldIdLst>
             <p14:sldId id="256"/>
           </p14:sldIdLst>
         </p14:section>
-        <p14:section name="Resumen" id="{3642bdfc-66e7-547d-a179-8465caa74647}">
+        <p14:section name="Resumen" id="{fca703bc-2ea9-64e6-8679-07809b0d9037}">
           <p14:sldIdLst>
             <p14:sldId id="257"/>
             <p14:sldId id="258"/>
@@ -132,7 +132,7 @@
             <p14:sldId id="260"/>
           </p14:sldIdLst>
         </p14:section>
-        <p14:section name="Cómo se armó" id="{5744a0e5-b678-8a53-b08b-aade5419bd66}">
+        <p14:section name="Cómo se armó" id="{bb4d7a26-f7ee-6625-f24f-01e2aee04ed6}">
           <p14:sldIdLst>
             <p14:sldId id="261"/>
             <p14:sldId id="262"/>
@@ -140,7 +140,7 @@
             <p14:sldId id="264"/>
           </p14:sldIdLst>
         </p14:section>
-        <p14:section name="Qué hacer" id="{f9c50539-40d4-7574-a319-a85bf86f7cef}">
+        <p14:section name="Qué hacer" id="{cbff2ff3-af3b-7c13-8aa5-de147a90e1ba}">
           <p14:sldIdLst>
             <p14:sldId id="265"/>
             <p14:sldId id="266"/>
@@ -4479,7 +4479,7 @@
           <a:p>
             <a:r>
               <a:rPr lang="en-US" dirty="0"/>
-              <a:t>Preguntas abiertas para el debate con el sector de microfinanzas. No son datos: son los dilemas que deja el diagnóstico (préstamo responsable, cobranza, competencia con billeteras y sostenibilidad de la cartera). El dato de mora en billeteras (31%) es de EcoGo-Universidad Austral, junio de 2026.</a:t>
+              <a:t>Preguntas abiertas para el debate con el sector de microfinanzas. Cada fila es una tensión entre dos objetivos que hay que equilibrar. No son datos: son los dilemas que deja el diagnóstico (préstamo responsable, cobranza, competencia con billeteras y sostenibilidad de la cartera). El dato de mora en billeteras (31%) es de EcoGo-Universidad Austral, junio de 2026.</a:t>
             </a:r>
             <a:endParaRPr lang="en-US" dirty="0"/>
           </a:p>
@@ -7526,18 +7526,54 @@
       </p:sp>
       <p:sp>
         <p:nvSpPr>
-          <p:cNvPr id="4" name="Pregunta 1"/>
+          <p:cNvPr id="4" name="Text 2"/>
+          <p:cNvSpPr txBox="1"/>
+          <p:nvPr/>
+        </p:nvSpPr>
+        <p:spPr>
+          <a:xfrm>
+            <a:off x="6766560" y="1463040"/>
+            <a:ext cx="4510735" cy="274320"/>
+          </a:xfrm>
+          <a:prstGeom prst="rect">
+            <a:avLst/>
+          </a:prstGeom>
+          <a:noFill/>
+          <a:ln/>
+        </p:spPr>
+        <p:txBody>
+          <a:bodyPr wrap="square" lIns="0" tIns="0" rIns="0" bIns="0" rtlCol="0" anchor="ctr"/>
+          <a:lstStyle/>
+          <a:p>
+            <a:pPr algn="ctr" indent="0" marL="0">
+              <a:buNone/>
+            </a:pPr>
+            <a:r>
+              <a:rPr lang="en-US" sz="1100" b="1" spc="150" kern="0" dirty="0">
+                <a:solidFill>
+                  <a:schemeClr val="accent5"/>
+                </a:solidFill>
+              </a:rPr>
+              <a:t>UN DILEMA EN CADA FRENTE</a:t>
+            </a:r>
+            <a:endParaRPr lang="en-US" sz="1100" dirty="0"/>
+          </a:p>
+        </p:txBody>
+      </p:sp>
+      <p:sp>
+        <p:nvSpPr>
+          <p:cNvPr id="5" name="Dilema 1"/>
           <p:cNvSpPr/>
           <p:nvPr/>
         </p:nvSpPr>
         <p:spPr>
           <a:xfrm>
             <a:off x="548640" y="1783080"/>
-            <a:ext cx="5410048" cy="1920240"/>
+            <a:ext cx="11094415" cy="1024128"/>
           </a:xfrm>
           <a:prstGeom prst="roundRect">
             <a:avLst>
-              <a:gd name="adj" fmla="val 7619"/>
+              <a:gd name="adj" fmla="val 14286"/>
             </a:avLst>
           </a:prstGeom>
           <a:solidFill>
@@ -7553,16 +7589,16 @@
       </p:sp>
       <p:sp>
         <p:nvSpPr>
-          <p:cNvPr id="5" name="Shape 3"/>
-          <p:cNvSpPr/>
-          <p:nvPr/>
-        </p:nvSpPr>
-        <p:spPr>
-          <a:xfrm>
-            <a:off x="822960" y="2057400"/>
-            <a:ext cx="548640" cy="548640"/>
-          </a:xfrm>
-          <a:prstGeom prst="ellipse">
+          <p:cNvPr id="6" name="Shape 4"/>
+          <p:cNvSpPr/>
+          <p:nvPr/>
+        </p:nvSpPr>
+        <p:spPr>
+          <a:xfrm>
+            <a:off x="548640" y="1947672"/>
+            <a:ext cx="73152" cy="694944"/>
+          </a:xfrm>
+          <a:prstGeom prst="rect">
             <a:avLst/>
           </a:prstGeom>
           <a:solidFill>
@@ -7573,14 +7609,14 @@
       </p:sp>
       <p:sp>
         <p:nvSpPr>
-          <p:cNvPr id="6" name="Text 4"/>
+          <p:cNvPr id="7" name="Text 5"/>
           <p:cNvSpPr txBox="1"/>
           <p:nvPr/>
         </p:nvSpPr>
         <p:spPr>
           <a:xfrm>
-            <a:off x="822960" y="2057400"/>
-            <a:ext cx="548640" cy="548640"/>
+            <a:off x="822960" y="1892808"/>
+            <a:ext cx="731520" cy="457200"/>
           </a:xfrm>
           <a:prstGeom prst="rect">
             <a:avLst/>
@@ -7592,16 +7628,16 @@
           <a:bodyPr wrap="square" lIns="0" tIns="0" rIns="0" bIns="0" rtlCol="0" anchor="ctr"/>
           <a:lstStyle/>
           <a:p>
-            <a:pPr algn="ctr" indent="0" marL="0">
+            <a:pPr indent="0" marL="0">
               <a:buNone/>
             </a:pPr>
             <a:r>
               <a:rPr lang="en-US" sz="2400" b="1" dirty="0">
                 <a:solidFill>
-                  <a:schemeClr val="bg1"/>
+                  <a:schemeClr val="accent3"/>
                 </a:solidFill>
               </a:rPr>
-              <a:t>?</a:t>
+              <a:t>01</a:t>
             </a:r>
             <a:endParaRPr lang="en-US" sz="2400" dirty="0"/>
           </a:p>
@@ -7609,14 +7645,14 @@
       </p:sp>
       <p:sp>
         <p:nvSpPr>
-          <p:cNvPr id="7" name="Text 5"/>
+          <p:cNvPr id="8" name="Text 6"/>
           <p:cNvSpPr txBox="1"/>
           <p:nvPr/>
         </p:nvSpPr>
         <p:spPr>
           <a:xfrm>
-            <a:off x="1554480" y="2057400"/>
-            <a:ext cx="4129888" cy="548640"/>
+            <a:off x="1554480" y="1892808"/>
+            <a:ext cx="4754880" cy="384048"/>
           </a:xfrm>
           <a:prstGeom prst="rect">
             <a:avLst/>
@@ -7632,27 +7668,27 @@
               <a:buNone/>
             </a:pPr>
             <a:r>
-              <a:rPr lang="en-US" sz="2000" b="1" dirty="0">
+              <a:rPr lang="en-US" sz="1800" b="1" dirty="0">
                 <a:solidFill>
                   <a:schemeClr val="tx1"/>
                 </a:solidFill>
               </a:rPr>
               <a:t>Prestar con responsabilidad</a:t>
             </a:r>
-            <a:endParaRPr lang="en-US" sz="2000" dirty="0"/>
-          </a:p>
-        </p:txBody>
-      </p:sp>
-      <p:sp>
-        <p:nvSpPr>
-          <p:cNvPr id="8" name="Text 6"/>
+            <a:endParaRPr lang="en-US" sz="1800" dirty="0"/>
+          </a:p>
+        </p:txBody>
+      </p:sp>
+      <p:sp>
+        <p:nvSpPr>
+          <p:cNvPr id="9" name="Text 7"/>
           <p:cNvSpPr txBox="1"/>
           <p:nvPr/>
         </p:nvSpPr>
         <p:spPr>
           <a:xfrm>
-            <a:off x="1554480" y="2697480"/>
-            <a:ext cx="4129888" cy="868680"/>
+            <a:off x="1554480" y="2276856"/>
+            <a:ext cx="4754880" cy="457200"/>
           </a:xfrm>
           <a:prstGeom prst="rect">
             <a:avLst/>
@@ -7668,31 +7704,208 @@
               <a:buNone/>
             </a:pPr>
             <a:r>
-              <a:rPr lang="en-US" sz="1600" dirty="0">
+              <a:rPr lang="en-US" sz="1300" dirty="0">
                 <a:solidFill>
                   <a:schemeClr val="tx2"/>
                 </a:solidFill>
               </a:rPr>
-              <a:t>¿Cómo medir la capacidad de pago cuando el ingreso cae y los gastos fijos suben?</a:t>
-            </a:r>
-            <a:endParaRPr lang="en-US" sz="1600" dirty="0"/>
-          </a:p>
-        </p:txBody>
-      </p:sp>
-      <p:sp>
-        <p:nvSpPr>
-          <p:cNvPr id="9" name="Pregunta 2"/>
-          <p:cNvSpPr/>
-          <p:nvPr/>
-        </p:nvSpPr>
-        <p:spPr>
-          <a:xfrm>
-            <a:off x="6233008" y="1783080"/>
-            <a:ext cx="5410048" cy="1920240"/>
+              <a:t>¿Cómo medir la capacidad de pago si el ingreso cae y los gastos fijos suben?</a:t>
+            </a:r>
+            <a:endParaRPr lang="en-US" sz="1300" dirty="0"/>
+          </a:p>
+        </p:txBody>
+      </p:sp>
+      <p:sp>
+        <p:nvSpPr>
+          <p:cNvPr id="10" name="Shape 8"/>
+          <p:cNvSpPr/>
+          <p:nvPr/>
+        </p:nvSpPr>
+        <p:spPr>
+          <a:xfrm>
+            <a:off x="6766560" y="2404872"/>
+            <a:ext cx="4510735" cy="0"/>
+          </a:xfrm>
+          <a:prstGeom prst="line">
+            <a:avLst/>
+          </a:prstGeom>
+          <a:noFill/>
+          <a:ln w="31750">
+            <a:solidFill>
+              <a:schemeClr val="accent6"/>
+            </a:solidFill>
+            <a:prstDash val="solid"/>
+          </a:ln>
+        </p:spPr>
+      </p:sp>
+      <p:sp>
+        <p:nvSpPr>
+          <p:cNvPr id="11" name="Shape 9"/>
+          <p:cNvSpPr/>
+          <p:nvPr/>
+        </p:nvSpPr>
+        <p:spPr>
+          <a:xfrm>
+            <a:off x="6766560" y="2340864"/>
+            <a:ext cx="128016" cy="128016"/>
+          </a:xfrm>
+          <a:prstGeom prst="ellipse">
+            <a:avLst/>
+          </a:prstGeom>
+          <a:solidFill>
+            <a:schemeClr val="accent4"/>
+          </a:solidFill>
+          <a:ln/>
+        </p:spPr>
+      </p:sp>
+      <p:sp>
+        <p:nvSpPr>
+          <p:cNvPr id="12" name="Shape 10"/>
+          <p:cNvSpPr/>
+          <p:nvPr/>
+        </p:nvSpPr>
+        <p:spPr>
+          <a:xfrm>
+            <a:off x="11149279" y="2340864"/>
+            <a:ext cx="128016" cy="128016"/>
+          </a:xfrm>
+          <a:prstGeom prst="ellipse">
+            <a:avLst/>
+          </a:prstGeom>
+          <a:solidFill>
+            <a:schemeClr val="accent4"/>
+          </a:solidFill>
+          <a:ln/>
+        </p:spPr>
+      </p:sp>
+      <p:sp>
+        <p:nvSpPr>
+          <p:cNvPr id="13" name="Shape 11"/>
+          <p:cNvSpPr/>
+          <p:nvPr/>
+        </p:nvSpPr>
+        <p:spPr>
+          <a:xfrm>
+            <a:off x="8820760" y="2203704"/>
+            <a:ext cx="402336" cy="402336"/>
+          </a:xfrm>
+          <a:prstGeom prst="ellipse">
+            <a:avLst/>
+          </a:prstGeom>
+          <a:solidFill>
+            <a:schemeClr val="accent3"/>
+          </a:solidFill>
+          <a:ln/>
+        </p:spPr>
+      </p:sp>
+      <p:sp>
+        <p:nvSpPr>
+          <p:cNvPr id="14" name="Shape 12"/>
+          <p:cNvSpPr/>
+          <p:nvPr/>
+        </p:nvSpPr>
+        <p:spPr>
+          <a:xfrm>
+            <a:off x="8885133" y="2268078"/>
+            <a:ext cx="273588" cy="273588"/>
+          </a:xfrm>
+          <a:prstGeom prst="ellipse">
+            <a:avLst/>
+          </a:prstGeom>
+          <a:ln w="16764">
+            <a:solidFill>
+              <a:srgbClr val="006E7A"/>
+            </a:solidFill>
+            <a:prstDash val="solid"/>
+          </a:ln>
+        </p:spPr>
+      </p:sp>
+      <p:sp>
+        <p:nvSpPr>
+          <p:cNvPr id="15" name="Text 13"/>
+          <p:cNvSpPr txBox="1"/>
+          <p:nvPr/>
+        </p:nvSpPr>
+        <p:spPr>
+          <a:xfrm>
+            <a:off x="6766560" y="1947672"/>
+            <a:ext cx="1935328" cy="292608"/>
+          </a:xfrm>
+          <a:prstGeom prst="rect">
+            <a:avLst/>
+          </a:prstGeom>
+          <a:noFill/>
+          <a:ln/>
+        </p:spPr>
+        <p:txBody>
+          <a:bodyPr wrap="square" lIns="0" tIns="0" rIns="0" bIns="0" rtlCol="0" anchor="b"/>
+          <a:lstStyle/>
+          <a:p>
+            <a:pPr algn="l" indent="0" marL="0">
+              <a:buNone/>
+            </a:pPr>
+            <a:r>
+              <a:rPr lang="en-US" sz="1300" b="1" dirty="0">
+                <a:solidFill>
+                  <a:schemeClr val="tx1"/>
+                </a:solidFill>
+              </a:rPr>
+              <a:t>Llegar a más gente</a:t>
+            </a:r>
+            <a:endParaRPr lang="en-US" sz="1300" dirty="0"/>
+          </a:p>
+        </p:txBody>
+      </p:sp>
+      <p:sp>
+        <p:nvSpPr>
+          <p:cNvPr id="16" name="Text 14"/>
+          <p:cNvSpPr txBox="1"/>
+          <p:nvPr/>
+        </p:nvSpPr>
+        <p:spPr>
+          <a:xfrm>
+            <a:off x="9341968" y="1947672"/>
+            <a:ext cx="1935328" cy="292608"/>
+          </a:xfrm>
+          <a:prstGeom prst="rect">
+            <a:avLst/>
+          </a:prstGeom>
+          <a:noFill/>
+          <a:ln/>
+        </p:spPr>
+        <p:txBody>
+          <a:bodyPr wrap="square" lIns="0" tIns="0" rIns="0" bIns="0" rtlCol="0" anchor="b"/>
+          <a:lstStyle/>
+          <a:p>
+            <a:pPr algn="r" indent="0" marL="0">
+              <a:buNone/>
+            </a:pPr>
+            <a:r>
+              <a:rPr lang="en-US" sz="1300" b="1" dirty="0">
+                <a:solidFill>
+                  <a:schemeClr val="tx1"/>
+                </a:solidFill>
+              </a:rPr>
+              <a:t>Asegurar el repago</a:t>
+            </a:r>
+            <a:endParaRPr lang="en-US" sz="1300" dirty="0"/>
+          </a:p>
+        </p:txBody>
+      </p:sp>
+      <p:sp>
+        <p:nvSpPr>
+          <p:cNvPr id="17" name="Dilema 2"/>
+          <p:cNvSpPr/>
+          <p:nvPr/>
+        </p:nvSpPr>
+        <p:spPr>
+          <a:xfrm>
+            <a:off x="548640" y="2898648"/>
+            <a:ext cx="11094415" cy="1024128"/>
           </a:xfrm>
           <a:prstGeom prst="roundRect">
             <a:avLst>
-              <a:gd name="adj" fmla="val 7619"/>
+              <a:gd name="adj" fmla="val 14286"/>
             </a:avLst>
           </a:prstGeom>
           <a:solidFill>
@@ -7708,16 +7921,16 @@
       </p:sp>
       <p:sp>
         <p:nvSpPr>
-          <p:cNvPr id="10" name="Shape 8"/>
-          <p:cNvSpPr/>
-          <p:nvPr/>
-        </p:nvSpPr>
-        <p:spPr>
-          <a:xfrm>
-            <a:off x="6507328" y="2057400"/>
-            <a:ext cx="548640" cy="548640"/>
-          </a:xfrm>
-          <a:prstGeom prst="ellipse">
+          <p:cNvPr id="18" name="Shape 16"/>
+          <p:cNvSpPr/>
+          <p:nvPr/>
+        </p:nvSpPr>
+        <p:spPr>
+          <a:xfrm>
+            <a:off x="548640" y="3063240"/>
+            <a:ext cx="73152" cy="694944"/>
+          </a:xfrm>
+          <a:prstGeom prst="rect">
             <a:avLst/>
           </a:prstGeom>
           <a:solidFill>
@@ -7728,14 +7941,14 @@
       </p:sp>
       <p:sp>
         <p:nvSpPr>
-          <p:cNvPr id="11" name="Text 9"/>
+          <p:cNvPr id="19" name="Text 17"/>
           <p:cNvSpPr txBox="1"/>
           <p:nvPr/>
         </p:nvSpPr>
         <p:spPr>
           <a:xfrm>
-            <a:off x="6507328" y="2057400"/>
-            <a:ext cx="548640" cy="548640"/>
+            <a:off x="822960" y="3008376"/>
+            <a:ext cx="731520" cy="457200"/>
           </a:xfrm>
           <a:prstGeom prst="rect">
             <a:avLst/>
@@ -7747,16 +7960,16 @@
           <a:bodyPr wrap="square" lIns="0" tIns="0" rIns="0" bIns="0" rtlCol="0" anchor="ctr"/>
           <a:lstStyle/>
           <a:p>
-            <a:pPr algn="ctr" indent="0" marL="0">
+            <a:pPr indent="0" marL="0">
               <a:buNone/>
             </a:pPr>
             <a:r>
               <a:rPr lang="en-US" sz="2400" b="1" dirty="0">
                 <a:solidFill>
-                  <a:schemeClr val="bg1"/>
+                  <a:schemeClr val="accent1"/>
                 </a:solidFill>
               </a:rPr>
-              <a:t>?</a:t>
+              <a:t>02</a:t>
             </a:r>
             <a:endParaRPr lang="en-US" sz="2400" dirty="0"/>
           </a:p>
@@ -7764,14 +7977,14 @@
       </p:sp>
       <p:sp>
         <p:nvSpPr>
-          <p:cNvPr id="12" name="Text 10"/>
+          <p:cNvPr id="20" name="Text 18"/>
           <p:cNvSpPr txBox="1"/>
           <p:nvPr/>
         </p:nvSpPr>
         <p:spPr>
           <a:xfrm>
-            <a:off x="7238848" y="2057400"/>
-            <a:ext cx="4129888" cy="548640"/>
+            <a:off x="1554480" y="3008376"/>
+            <a:ext cx="4754880" cy="384048"/>
           </a:xfrm>
           <a:prstGeom prst="rect">
             <a:avLst/>
@@ -7787,27 +8000,27 @@
               <a:buNone/>
             </a:pPr>
             <a:r>
-              <a:rPr lang="en-US" sz="2000" b="1" dirty="0">
+              <a:rPr lang="en-US" sz="1800" b="1" dirty="0">
                 <a:solidFill>
                   <a:schemeClr val="tx1"/>
                 </a:solidFill>
               </a:rPr>
               <a:t>Cobrar sin hundir</a:t>
             </a:r>
-            <a:endParaRPr lang="en-US" sz="2000" dirty="0"/>
-          </a:p>
-        </p:txBody>
-      </p:sp>
-      <p:sp>
-        <p:nvSpPr>
-          <p:cNvPr id="13" name="Text 11"/>
+            <a:endParaRPr lang="en-US" sz="1800" dirty="0"/>
+          </a:p>
+        </p:txBody>
+      </p:sp>
+      <p:sp>
+        <p:nvSpPr>
+          <p:cNvPr id="21" name="Text 19"/>
           <p:cNvSpPr txBox="1"/>
           <p:nvPr/>
         </p:nvSpPr>
         <p:spPr>
           <a:xfrm>
-            <a:off x="7238848" y="2697480"/>
-            <a:ext cx="4129888" cy="868680"/>
+            <a:off x="1554480" y="3392424"/>
+            <a:ext cx="4754880" cy="457200"/>
           </a:xfrm>
           <a:prstGeom prst="rect">
             <a:avLst/>
@@ -7823,31 +8036,208 @@
               <a:buNone/>
             </a:pPr>
             <a:r>
-              <a:rPr lang="en-US" sz="1600" dirty="0">
+              <a:rPr lang="en-US" sz="1300" dirty="0">
                 <a:solidFill>
                   <a:schemeClr val="tx2"/>
                 </a:solidFill>
               </a:rPr>
-              <a:t>¿Qué prácticas de cobranza y de reestructuración sostienen a la vez al cliente y a la cartera?</a:t>
-            </a:r>
-            <a:endParaRPr lang="en-US" sz="1600" dirty="0"/>
-          </a:p>
-        </p:txBody>
-      </p:sp>
-      <p:sp>
-        <p:nvSpPr>
-          <p:cNvPr id="14" name="Pregunta 3"/>
-          <p:cNvSpPr/>
-          <p:nvPr/>
-        </p:nvSpPr>
-        <p:spPr>
-          <a:xfrm>
-            <a:off x="548640" y="3977640"/>
-            <a:ext cx="5410048" cy="1920240"/>
+              <a:t>¿Qué cobranza y qué reestructuración sostienen al cliente y a la cartera?</a:t>
+            </a:r>
+            <a:endParaRPr lang="en-US" sz="1300" dirty="0"/>
+          </a:p>
+        </p:txBody>
+      </p:sp>
+      <p:sp>
+        <p:nvSpPr>
+          <p:cNvPr id="22" name="Shape 20"/>
+          <p:cNvSpPr/>
+          <p:nvPr/>
+        </p:nvSpPr>
+        <p:spPr>
+          <a:xfrm>
+            <a:off x="6766560" y="3520440"/>
+            <a:ext cx="4510735" cy="0"/>
+          </a:xfrm>
+          <a:prstGeom prst="line">
+            <a:avLst/>
+          </a:prstGeom>
+          <a:noFill/>
+          <a:ln w="31750">
+            <a:solidFill>
+              <a:schemeClr val="accent6"/>
+            </a:solidFill>
+            <a:prstDash val="solid"/>
+          </a:ln>
+        </p:spPr>
+      </p:sp>
+      <p:sp>
+        <p:nvSpPr>
+          <p:cNvPr id="23" name="Shape 21"/>
+          <p:cNvSpPr/>
+          <p:nvPr/>
+        </p:nvSpPr>
+        <p:spPr>
+          <a:xfrm>
+            <a:off x="6766560" y="3456432"/>
+            <a:ext cx="128016" cy="128016"/>
+          </a:xfrm>
+          <a:prstGeom prst="ellipse">
+            <a:avLst/>
+          </a:prstGeom>
+          <a:solidFill>
+            <a:schemeClr val="accent4"/>
+          </a:solidFill>
+          <a:ln/>
+        </p:spPr>
+      </p:sp>
+      <p:sp>
+        <p:nvSpPr>
+          <p:cNvPr id="24" name="Shape 22"/>
+          <p:cNvSpPr/>
+          <p:nvPr/>
+        </p:nvSpPr>
+        <p:spPr>
+          <a:xfrm>
+            <a:off x="11149279" y="3456432"/>
+            <a:ext cx="128016" cy="128016"/>
+          </a:xfrm>
+          <a:prstGeom prst="ellipse">
+            <a:avLst/>
+          </a:prstGeom>
+          <a:solidFill>
+            <a:schemeClr val="accent4"/>
+          </a:solidFill>
+          <a:ln/>
+        </p:spPr>
+      </p:sp>
+      <p:sp>
+        <p:nvSpPr>
+          <p:cNvPr id="25" name="Shape 23"/>
+          <p:cNvSpPr/>
+          <p:nvPr/>
+        </p:nvSpPr>
+        <p:spPr>
+          <a:xfrm>
+            <a:off x="8820760" y="3319272"/>
+            <a:ext cx="402336" cy="402336"/>
+          </a:xfrm>
+          <a:prstGeom prst="ellipse">
+            <a:avLst/>
+          </a:prstGeom>
+          <a:solidFill>
+            <a:schemeClr val="accent1"/>
+          </a:solidFill>
+          <a:ln/>
+        </p:spPr>
+      </p:sp>
+      <p:sp>
+        <p:nvSpPr>
+          <p:cNvPr id="26" name="Shape 24"/>
+          <p:cNvSpPr/>
+          <p:nvPr/>
+        </p:nvSpPr>
+        <p:spPr>
+          <a:xfrm>
+            <a:off x="8885133" y="3383646"/>
+            <a:ext cx="273588" cy="273588"/>
+          </a:xfrm>
+          <a:prstGeom prst="ellipse">
+            <a:avLst/>
+          </a:prstGeom>
+          <a:ln w="16764">
+            <a:solidFill>
+              <a:srgbClr val="B8432F"/>
+            </a:solidFill>
+            <a:prstDash val="solid"/>
+          </a:ln>
+        </p:spPr>
+      </p:sp>
+      <p:sp>
+        <p:nvSpPr>
+          <p:cNvPr id="27" name="Text 25"/>
+          <p:cNvSpPr txBox="1"/>
+          <p:nvPr/>
+        </p:nvSpPr>
+        <p:spPr>
+          <a:xfrm>
+            <a:off x="6766560" y="3063240"/>
+            <a:ext cx="1935328" cy="292608"/>
+          </a:xfrm>
+          <a:prstGeom prst="rect">
+            <a:avLst/>
+          </a:prstGeom>
+          <a:noFill/>
+          <a:ln/>
+        </p:spPr>
+        <p:txBody>
+          <a:bodyPr wrap="square" lIns="0" tIns="0" rIns="0" bIns="0" rtlCol="0" anchor="b"/>
+          <a:lstStyle/>
+          <a:p>
+            <a:pPr algn="l" indent="0" marL="0">
+              <a:buNone/>
+            </a:pPr>
+            <a:r>
+              <a:rPr lang="en-US" sz="1300" b="1" dirty="0">
+                <a:solidFill>
+                  <a:schemeClr val="tx1"/>
+                </a:solidFill>
+              </a:rPr>
+              <a:t>Recuperar la cartera</a:t>
+            </a:r>
+            <a:endParaRPr lang="en-US" sz="1300" dirty="0"/>
+          </a:p>
+        </p:txBody>
+      </p:sp>
+      <p:sp>
+        <p:nvSpPr>
+          <p:cNvPr id="28" name="Text 26"/>
+          <p:cNvSpPr txBox="1"/>
+          <p:nvPr/>
+        </p:nvSpPr>
+        <p:spPr>
+          <a:xfrm>
+            <a:off x="9341968" y="3063240"/>
+            <a:ext cx="1935328" cy="292608"/>
+          </a:xfrm>
+          <a:prstGeom prst="rect">
+            <a:avLst/>
+          </a:prstGeom>
+          <a:noFill/>
+          <a:ln/>
+        </p:spPr>
+        <p:txBody>
+          <a:bodyPr wrap="square" lIns="0" tIns="0" rIns="0" bIns="0" rtlCol="0" anchor="b"/>
+          <a:lstStyle/>
+          <a:p>
+            <a:pPr algn="r" indent="0" marL="0">
+              <a:buNone/>
+            </a:pPr>
+            <a:r>
+              <a:rPr lang="en-US" sz="1300" b="1" dirty="0">
+                <a:solidFill>
+                  <a:schemeClr val="tx1"/>
+                </a:solidFill>
+              </a:rPr>
+              <a:t>Sostener al cliente</a:t>
+            </a:r>
+            <a:endParaRPr lang="en-US" sz="1300" dirty="0"/>
+          </a:p>
+        </p:txBody>
+      </p:sp>
+      <p:sp>
+        <p:nvSpPr>
+          <p:cNvPr id="29" name="Dilema 3"/>
+          <p:cNvSpPr/>
+          <p:nvPr/>
+        </p:nvSpPr>
+        <p:spPr>
+          <a:xfrm>
+            <a:off x="548640" y="4014216"/>
+            <a:ext cx="11094415" cy="1024128"/>
           </a:xfrm>
           <a:prstGeom prst="roundRect">
             <a:avLst>
-              <a:gd name="adj" fmla="val 7619"/>
+              <a:gd name="adj" fmla="val 14286"/>
             </a:avLst>
           </a:prstGeom>
           <a:solidFill>
@@ -7863,16 +8253,16 @@
       </p:sp>
       <p:sp>
         <p:nvSpPr>
-          <p:cNvPr id="15" name="Shape 13"/>
-          <p:cNvSpPr/>
-          <p:nvPr/>
-        </p:nvSpPr>
-        <p:spPr>
-          <a:xfrm>
-            <a:off x="822960" y="4251960"/>
-            <a:ext cx="548640" cy="548640"/>
-          </a:xfrm>
-          <a:prstGeom prst="ellipse">
+          <p:cNvPr id="30" name="Shape 28"/>
+          <p:cNvSpPr/>
+          <p:nvPr/>
+        </p:nvSpPr>
+        <p:spPr>
+          <a:xfrm>
+            <a:off x="548640" y="4178808"/>
+            <a:ext cx="73152" cy="694944"/>
+          </a:xfrm>
+          <a:prstGeom prst="rect">
             <a:avLst/>
           </a:prstGeom>
           <a:solidFill>
@@ -7883,14 +8273,14 @@
       </p:sp>
       <p:sp>
         <p:nvSpPr>
-          <p:cNvPr id="16" name="Text 14"/>
+          <p:cNvPr id="31" name="Text 29"/>
           <p:cNvSpPr txBox="1"/>
           <p:nvPr/>
         </p:nvSpPr>
         <p:spPr>
           <a:xfrm>
-            <a:off x="822960" y="4251960"/>
-            <a:ext cx="548640" cy="548640"/>
+            <a:off x="822960" y="4123944"/>
+            <a:ext cx="731520" cy="457200"/>
           </a:xfrm>
           <a:prstGeom prst="rect">
             <a:avLst/>
@@ -7902,16 +8292,16 @@
           <a:bodyPr wrap="square" lIns="0" tIns="0" rIns="0" bIns="0" rtlCol="0" anchor="ctr"/>
           <a:lstStyle/>
           <a:p>
-            <a:pPr algn="ctr" indent="0" marL="0">
+            <a:pPr indent="0" marL="0">
               <a:buNone/>
             </a:pPr>
             <a:r>
               <a:rPr lang="en-US" sz="2400" b="1" dirty="0">
                 <a:solidFill>
-                  <a:schemeClr val="tx1"/>
+                  <a:schemeClr val="accent2"/>
                 </a:solidFill>
               </a:rPr>
-              <a:t>?</a:t>
+              <a:t>03</a:t>
             </a:r>
             <a:endParaRPr lang="en-US" sz="2400" dirty="0"/>
           </a:p>
@@ -7919,14 +8309,14 @@
       </p:sp>
       <p:sp>
         <p:nvSpPr>
-          <p:cNvPr id="17" name="Text 15"/>
+          <p:cNvPr id="32" name="Text 30"/>
           <p:cNvSpPr txBox="1"/>
           <p:nvPr/>
         </p:nvSpPr>
         <p:spPr>
           <a:xfrm>
-            <a:off x="1554480" y="4251960"/>
-            <a:ext cx="4129888" cy="548640"/>
+            <a:off x="1554480" y="4123944"/>
+            <a:ext cx="4754880" cy="384048"/>
           </a:xfrm>
           <a:prstGeom prst="rect">
             <a:avLst/>
@@ -7942,27 +8332,27 @@
               <a:buNone/>
             </a:pPr>
             <a:r>
-              <a:rPr lang="en-US" sz="2000" b="1" dirty="0">
+              <a:rPr lang="en-US" sz="1800" b="1" dirty="0">
                 <a:solidFill>
                   <a:schemeClr val="tx1"/>
                 </a:solidFill>
               </a:rPr>
               <a:t>Competir con el crédito de un clic</a:t>
             </a:r>
-            <a:endParaRPr lang="en-US" sz="2000" dirty="0"/>
-          </a:p>
-        </p:txBody>
-      </p:sp>
-      <p:sp>
-        <p:nvSpPr>
-          <p:cNvPr id="18" name="Text 16"/>
+            <a:endParaRPr lang="en-US" sz="1800" dirty="0"/>
+          </a:p>
+        </p:txBody>
+      </p:sp>
+      <p:sp>
+        <p:nvSpPr>
+          <p:cNvPr id="33" name="Text 31"/>
           <p:cNvSpPr txBox="1"/>
           <p:nvPr/>
         </p:nvSpPr>
         <p:spPr>
           <a:xfrm>
-            <a:off x="1554480" y="4892040"/>
-            <a:ext cx="4129888" cy="868680"/>
+            <a:off x="1554480" y="4507992"/>
+            <a:ext cx="4754880" cy="457200"/>
           </a:xfrm>
           <a:prstGeom prst="rect">
             <a:avLst/>
@@ -7978,31 +8368,208 @@
               <a:buNone/>
             </a:pPr>
             <a:r>
-              <a:rPr lang="en-US" sz="1600" dirty="0">
+              <a:rPr lang="en-US" sz="1300" dirty="0">
                 <a:solidFill>
                   <a:schemeClr val="tx2"/>
                 </a:solidFill>
               </a:rPr>
-              <a:t>¿Qué ventaja da el vínculo cercano frente a las billeteras, donde la mora ya supera el 30%?</a:t>
-            </a:r>
-            <a:endParaRPr lang="en-US" sz="1600" dirty="0"/>
-          </a:p>
-        </p:txBody>
-      </p:sp>
-      <p:sp>
-        <p:nvSpPr>
-          <p:cNvPr id="19" name="Pregunta 4"/>
-          <p:cNvSpPr/>
-          <p:nvPr/>
-        </p:nvSpPr>
-        <p:spPr>
-          <a:xfrm>
-            <a:off x="6233008" y="3977640"/>
-            <a:ext cx="5410048" cy="1920240"/>
+              <a:t>¿Qué ventaja da el vínculo cercano frente a billeteras con mora de más del 30%?</a:t>
+            </a:r>
+            <a:endParaRPr lang="en-US" sz="1300" dirty="0"/>
+          </a:p>
+        </p:txBody>
+      </p:sp>
+      <p:sp>
+        <p:nvSpPr>
+          <p:cNvPr id="34" name="Shape 32"/>
+          <p:cNvSpPr/>
+          <p:nvPr/>
+        </p:nvSpPr>
+        <p:spPr>
+          <a:xfrm>
+            <a:off x="6766560" y="4636008"/>
+            <a:ext cx="4510735" cy="0"/>
+          </a:xfrm>
+          <a:prstGeom prst="line">
+            <a:avLst/>
+          </a:prstGeom>
+          <a:noFill/>
+          <a:ln w="31750">
+            <a:solidFill>
+              <a:schemeClr val="accent6"/>
+            </a:solidFill>
+            <a:prstDash val="solid"/>
+          </a:ln>
+        </p:spPr>
+      </p:sp>
+      <p:sp>
+        <p:nvSpPr>
+          <p:cNvPr id="35" name="Shape 33"/>
+          <p:cNvSpPr/>
+          <p:nvPr/>
+        </p:nvSpPr>
+        <p:spPr>
+          <a:xfrm>
+            <a:off x="6766560" y="4572000"/>
+            <a:ext cx="128016" cy="128016"/>
+          </a:xfrm>
+          <a:prstGeom prst="ellipse">
+            <a:avLst/>
+          </a:prstGeom>
+          <a:solidFill>
+            <a:schemeClr val="accent4"/>
+          </a:solidFill>
+          <a:ln/>
+        </p:spPr>
+      </p:sp>
+      <p:sp>
+        <p:nvSpPr>
+          <p:cNvPr id="36" name="Shape 34"/>
+          <p:cNvSpPr/>
+          <p:nvPr/>
+        </p:nvSpPr>
+        <p:spPr>
+          <a:xfrm>
+            <a:off x="11149279" y="4572000"/>
+            <a:ext cx="128016" cy="128016"/>
+          </a:xfrm>
+          <a:prstGeom prst="ellipse">
+            <a:avLst/>
+          </a:prstGeom>
+          <a:solidFill>
+            <a:schemeClr val="accent4"/>
+          </a:solidFill>
+          <a:ln/>
+        </p:spPr>
+      </p:sp>
+      <p:sp>
+        <p:nvSpPr>
+          <p:cNvPr id="37" name="Shape 35"/>
+          <p:cNvSpPr/>
+          <p:nvPr/>
+        </p:nvSpPr>
+        <p:spPr>
+          <a:xfrm>
+            <a:off x="8820760" y="4434840"/>
+            <a:ext cx="402336" cy="402336"/>
+          </a:xfrm>
+          <a:prstGeom prst="ellipse">
+            <a:avLst/>
+          </a:prstGeom>
+          <a:solidFill>
+            <a:schemeClr val="accent2"/>
+          </a:solidFill>
+          <a:ln/>
+        </p:spPr>
+      </p:sp>
+      <p:sp>
+        <p:nvSpPr>
+          <p:cNvPr id="38" name="Shape 36"/>
+          <p:cNvSpPr/>
+          <p:nvPr/>
+        </p:nvSpPr>
+        <p:spPr>
+          <a:xfrm>
+            <a:off x="8885133" y="4499214"/>
+            <a:ext cx="273588" cy="273588"/>
+          </a:xfrm>
+          <a:prstGeom prst="ellipse">
+            <a:avLst/>
+          </a:prstGeom>
+          <a:ln w="16764">
+            <a:solidFill>
+              <a:srgbClr val="C98A12"/>
+            </a:solidFill>
+            <a:prstDash val="solid"/>
+          </a:ln>
+        </p:spPr>
+      </p:sp>
+      <p:sp>
+        <p:nvSpPr>
+          <p:cNvPr id="39" name="Text 37"/>
+          <p:cNvSpPr txBox="1"/>
+          <p:nvPr/>
+        </p:nvSpPr>
+        <p:spPr>
+          <a:xfrm>
+            <a:off x="6766560" y="4178808"/>
+            <a:ext cx="1935328" cy="292608"/>
+          </a:xfrm>
+          <a:prstGeom prst="rect">
+            <a:avLst/>
+          </a:prstGeom>
+          <a:noFill/>
+          <a:ln/>
+        </p:spPr>
+        <p:txBody>
+          <a:bodyPr wrap="square" lIns="0" tIns="0" rIns="0" bIns="0" rtlCol="0" anchor="b"/>
+          <a:lstStyle/>
+          <a:p>
+            <a:pPr algn="l" indent="0" marL="0">
+              <a:buNone/>
+            </a:pPr>
+            <a:r>
+              <a:rPr lang="en-US" sz="1300" b="1" dirty="0">
+                <a:solidFill>
+                  <a:schemeClr val="tx1"/>
+                </a:solidFill>
+              </a:rPr>
+              <a:t>La velocidad del clic</a:t>
+            </a:r>
+            <a:endParaRPr lang="en-US" sz="1300" dirty="0"/>
+          </a:p>
+        </p:txBody>
+      </p:sp>
+      <p:sp>
+        <p:nvSpPr>
+          <p:cNvPr id="40" name="Text 38"/>
+          <p:cNvSpPr txBox="1"/>
+          <p:nvPr/>
+        </p:nvSpPr>
+        <p:spPr>
+          <a:xfrm>
+            <a:off x="9341968" y="4178808"/>
+            <a:ext cx="1935328" cy="292608"/>
+          </a:xfrm>
+          <a:prstGeom prst="rect">
+            <a:avLst/>
+          </a:prstGeom>
+          <a:noFill/>
+          <a:ln/>
+        </p:spPr>
+        <p:txBody>
+          <a:bodyPr wrap="square" lIns="0" tIns="0" rIns="0" bIns="0" rtlCol="0" anchor="b"/>
+          <a:lstStyle/>
+          <a:p>
+            <a:pPr algn="r" indent="0" marL="0">
+              <a:buNone/>
+            </a:pPr>
+            <a:r>
+              <a:rPr lang="en-US" sz="1300" b="1" dirty="0">
+                <a:solidFill>
+                  <a:schemeClr val="tx1"/>
+                </a:solidFill>
+              </a:rPr>
+              <a:t>El vínculo cercano</a:t>
+            </a:r>
+            <a:endParaRPr lang="en-US" sz="1300" dirty="0"/>
+          </a:p>
+        </p:txBody>
+      </p:sp>
+      <p:sp>
+        <p:nvSpPr>
+          <p:cNvPr id="41" name="Dilema 4"/>
+          <p:cNvSpPr/>
+          <p:nvPr/>
+        </p:nvSpPr>
+        <p:spPr>
+          <a:xfrm>
+            <a:off x="548640" y="5129784"/>
+            <a:ext cx="11094415" cy="1024128"/>
           </a:xfrm>
           <a:prstGeom prst="roundRect">
             <a:avLst>
-              <a:gd name="adj" fmla="val 7619"/>
+              <a:gd name="adj" fmla="val 14286"/>
             </a:avLst>
           </a:prstGeom>
           <a:solidFill>
@@ -8018,16 +8585,16 @@
       </p:sp>
       <p:sp>
         <p:nvSpPr>
-          <p:cNvPr id="20" name="Shape 18"/>
-          <p:cNvSpPr/>
-          <p:nvPr/>
-        </p:nvSpPr>
-        <p:spPr>
-          <a:xfrm>
-            <a:off x="6507328" y="4251960"/>
-            <a:ext cx="548640" cy="548640"/>
-          </a:xfrm>
-          <a:prstGeom prst="ellipse">
+          <p:cNvPr id="42" name="Shape 40"/>
+          <p:cNvSpPr/>
+          <p:nvPr/>
+        </p:nvSpPr>
+        <p:spPr>
+          <a:xfrm>
+            <a:off x="548640" y="5294376"/>
+            <a:ext cx="73152" cy="694944"/>
+          </a:xfrm>
+          <a:prstGeom prst="rect">
             <a:avLst/>
           </a:prstGeom>
           <a:solidFill>
@@ -8038,14 +8605,14 @@
       </p:sp>
       <p:sp>
         <p:nvSpPr>
-          <p:cNvPr id="21" name="Text 19"/>
+          <p:cNvPr id="43" name="Text 41"/>
           <p:cNvSpPr txBox="1"/>
           <p:nvPr/>
         </p:nvSpPr>
         <p:spPr>
           <a:xfrm>
-            <a:off x="6507328" y="4251960"/>
-            <a:ext cx="548640" cy="548640"/>
+            <a:off x="822960" y="5239512"/>
+            <a:ext cx="731520" cy="457200"/>
           </a:xfrm>
           <a:prstGeom prst="rect">
             <a:avLst/>
@@ -8057,16 +8624,16 @@
           <a:bodyPr wrap="square" lIns="0" tIns="0" rIns="0" bIns="0" rtlCol="0" anchor="ctr"/>
           <a:lstStyle/>
           <a:p>
-            <a:pPr algn="ctr" indent="0" marL="0">
+            <a:pPr indent="0" marL="0">
               <a:buNone/>
             </a:pPr>
             <a:r>
               <a:rPr lang="en-US" sz="2400" b="1" dirty="0">
                 <a:solidFill>
-                  <a:schemeClr val="bg1"/>
+                  <a:schemeClr val="tx1"/>
                 </a:solidFill>
               </a:rPr>
-              <a:t>?</a:t>
+              <a:t>04</a:t>
             </a:r>
             <a:endParaRPr lang="en-US" sz="2400" dirty="0"/>
           </a:p>
@@ -8074,14 +8641,14 @@
       </p:sp>
       <p:sp>
         <p:nvSpPr>
-          <p:cNvPr id="22" name="Text 20"/>
+          <p:cNvPr id="44" name="Text 42"/>
           <p:cNvSpPr txBox="1"/>
           <p:nvPr/>
         </p:nvSpPr>
         <p:spPr>
           <a:xfrm>
-            <a:off x="7238848" y="4251960"/>
-            <a:ext cx="4129888" cy="548640"/>
+            <a:off x="1554480" y="5239512"/>
+            <a:ext cx="4754880" cy="384048"/>
           </a:xfrm>
           <a:prstGeom prst="rect">
             <a:avLst/>
@@ -8097,27 +8664,27 @@
               <a:buNone/>
             </a:pPr>
             <a:r>
-              <a:rPr lang="en-US" sz="2000" b="1" dirty="0">
+              <a:rPr lang="en-US" sz="1800" b="1" dirty="0">
                 <a:solidFill>
                   <a:schemeClr val="tx1"/>
                 </a:solidFill>
               </a:rPr>
               <a:t>Cuidar la cartera sin excluir</a:t>
             </a:r>
-            <a:endParaRPr lang="en-US" sz="2000" dirty="0"/>
-          </a:p>
-        </p:txBody>
-      </p:sp>
-      <p:sp>
-        <p:nvSpPr>
-          <p:cNvPr id="23" name="Text 21"/>
+            <a:endParaRPr lang="en-US" sz="1800" dirty="0"/>
+          </a:p>
+        </p:txBody>
+      </p:sp>
+      <p:sp>
+        <p:nvSpPr>
+          <p:cNvPr id="45" name="Text 43"/>
           <p:cNvSpPr txBox="1"/>
           <p:nvPr/>
         </p:nvSpPr>
         <p:spPr>
           <a:xfrm>
-            <a:off x="7238848" y="4892040"/>
-            <a:ext cx="4129888" cy="868680"/>
+            <a:off x="1554480" y="5623560"/>
+            <a:ext cx="4754880" cy="457200"/>
           </a:xfrm>
           <a:prstGeom prst="rect">
             <a:avLst/>
@@ -8133,14 +8700,191 @@
               <a:buNone/>
             </a:pPr>
             <a:r>
-              <a:rPr lang="en-US" sz="1600" dirty="0">
+              <a:rPr lang="en-US" sz="1300" dirty="0">
                 <a:solidFill>
                   <a:schemeClr val="tx2"/>
                 </a:solidFill>
               </a:rPr>
               <a:t>¿Cómo bajar la mora sin dejar afuera a quienes más necesitan crédito?</a:t>
             </a:r>
-            <a:endParaRPr lang="en-US" sz="1600" dirty="0"/>
+            <a:endParaRPr lang="en-US" sz="1300" dirty="0"/>
+          </a:p>
+        </p:txBody>
+      </p:sp>
+      <p:sp>
+        <p:nvSpPr>
+          <p:cNvPr id="46" name="Shape 44"/>
+          <p:cNvSpPr/>
+          <p:nvPr/>
+        </p:nvSpPr>
+        <p:spPr>
+          <a:xfrm>
+            <a:off x="6766560" y="5751576"/>
+            <a:ext cx="4510735" cy="0"/>
+          </a:xfrm>
+          <a:prstGeom prst="line">
+            <a:avLst/>
+          </a:prstGeom>
+          <a:noFill/>
+          <a:ln w="31750">
+            <a:solidFill>
+              <a:schemeClr val="accent6"/>
+            </a:solidFill>
+            <a:prstDash val="solid"/>
+          </a:ln>
+        </p:spPr>
+      </p:sp>
+      <p:sp>
+        <p:nvSpPr>
+          <p:cNvPr id="47" name="Shape 45"/>
+          <p:cNvSpPr/>
+          <p:nvPr/>
+        </p:nvSpPr>
+        <p:spPr>
+          <a:xfrm>
+            <a:off x="6766560" y="5687568"/>
+            <a:ext cx="128016" cy="128016"/>
+          </a:xfrm>
+          <a:prstGeom prst="ellipse">
+            <a:avLst/>
+          </a:prstGeom>
+          <a:solidFill>
+            <a:schemeClr val="accent4"/>
+          </a:solidFill>
+          <a:ln/>
+        </p:spPr>
+      </p:sp>
+      <p:sp>
+        <p:nvSpPr>
+          <p:cNvPr id="48" name="Shape 46"/>
+          <p:cNvSpPr/>
+          <p:nvPr/>
+        </p:nvSpPr>
+        <p:spPr>
+          <a:xfrm>
+            <a:off x="11149279" y="5687568"/>
+            <a:ext cx="128016" cy="128016"/>
+          </a:xfrm>
+          <a:prstGeom prst="ellipse">
+            <a:avLst/>
+          </a:prstGeom>
+          <a:solidFill>
+            <a:schemeClr val="accent4"/>
+          </a:solidFill>
+          <a:ln/>
+        </p:spPr>
+      </p:sp>
+      <p:sp>
+        <p:nvSpPr>
+          <p:cNvPr id="49" name="Shape 47"/>
+          <p:cNvSpPr/>
+          <p:nvPr/>
+        </p:nvSpPr>
+        <p:spPr>
+          <a:xfrm>
+            <a:off x="8820760" y="5550408"/>
+            <a:ext cx="402336" cy="402336"/>
+          </a:xfrm>
+          <a:prstGeom prst="ellipse">
+            <a:avLst/>
+          </a:prstGeom>
+          <a:solidFill>
+            <a:schemeClr val="tx1"/>
+          </a:solidFill>
+          <a:ln/>
+        </p:spPr>
+      </p:sp>
+      <p:sp>
+        <p:nvSpPr>
+          <p:cNvPr id="50" name="Shape 48"/>
+          <p:cNvSpPr/>
+          <p:nvPr/>
+        </p:nvSpPr>
+        <p:spPr>
+          <a:xfrm>
+            <a:off x="8885133" y="5614782"/>
+            <a:ext cx="273588" cy="273588"/>
+          </a:xfrm>
+          <a:prstGeom prst="ellipse">
+            <a:avLst/>
+          </a:prstGeom>
+          <a:ln w="16764">
+            <a:solidFill>
+              <a:srgbClr val="FFFFFF"/>
+            </a:solidFill>
+            <a:prstDash val="solid"/>
+          </a:ln>
+        </p:spPr>
+      </p:sp>
+      <p:sp>
+        <p:nvSpPr>
+          <p:cNvPr id="51" name="Text 49"/>
+          <p:cNvSpPr txBox="1"/>
+          <p:nvPr/>
+        </p:nvSpPr>
+        <p:spPr>
+          <a:xfrm>
+            <a:off x="6766560" y="5294376"/>
+            <a:ext cx="1935328" cy="292608"/>
+          </a:xfrm>
+          <a:prstGeom prst="rect">
+            <a:avLst/>
+          </a:prstGeom>
+          <a:noFill/>
+          <a:ln/>
+        </p:spPr>
+        <p:txBody>
+          <a:bodyPr wrap="square" lIns="0" tIns="0" rIns="0" bIns="0" rtlCol="0" anchor="b"/>
+          <a:lstStyle/>
+          <a:p>
+            <a:pPr algn="l" indent="0" marL="0">
+              <a:buNone/>
+            </a:pPr>
+            <a:r>
+              <a:rPr lang="en-US" sz="1300" b="1" dirty="0">
+                <a:solidFill>
+                  <a:schemeClr val="tx1"/>
+                </a:solidFill>
+              </a:rPr>
+              <a:t>Bajar la mora</a:t>
+            </a:r>
+            <a:endParaRPr lang="en-US" sz="1300" dirty="0"/>
+          </a:p>
+        </p:txBody>
+      </p:sp>
+      <p:sp>
+        <p:nvSpPr>
+          <p:cNvPr id="52" name="Text 50"/>
+          <p:cNvSpPr txBox="1"/>
+          <p:nvPr/>
+        </p:nvSpPr>
+        <p:spPr>
+          <a:xfrm>
+            <a:off x="9341968" y="5294376"/>
+            <a:ext cx="1935328" cy="292608"/>
+          </a:xfrm>
+          <a:prstGeom prst="rect">
+            <a:avLst/>
+          </a:prstGeom>
+          <a:noFill/>
+          <a:ln/>
+        </p:spPr>
+        <p:txBody>
+          <a:bodyPr wrap="square" lIns="0" tIns="0" rIns="0" bIns="0" rtlCol="0" anchor="b"/>
+          <a:lstStyle/>
+          <a:p>
+            <a:pPr algn="r" indent="0" marL="0">
+              <a:buNone/>
+            </a:pPr>
+            <a:r>
+              <a:rPr lang="en-US" sz="1300" b="1" dirty="0">
+                <a:solidFill>
+                  <a:schemeClr val="tx1"/>
+                </a:solidFill>
+              </a:rPr>
+              <a:t>No dejar a nadie afuera</a:t>
+            </a:r>
+            <a:endParaRPr lang="en-US" sz="1300" dirty="0"/>
           </a:p>
         </p:txBody>
       </p:sp>

</xml_diff>